<commit_message>
Simplify vendor comparison table and cite the source on-slide
- Remove the visits per keyword column. The ratio still carries the efficiency
  point, so it moves into the left read-out as prose.
- Add a source line directly under the table naming the Semrush database and
  snapshot date, and explaining what Authority measures.
- Reorder rows with Komprise first, then by monthly traffic descending, now that
  the table is no longer sorted by a derived column.

A pages indexed in Google column was requested and is not included. SOURCES.md
records why: that figure is not obtainable for competitor domains from any
source available here.

Co-Authored-By: Claude Opus 5 <noreply@anthropic.com>
Claude-Session: https://claude.ai/code/session_01Qb9Qq8GcnmrwCpYXA3jWR9
</commit_message>
<xml_diff>
--- a/Komprise_Vendor_Comparison_Sep2026.pptx
+++ b/Komprise_Vendor_Comparison_Sep2026.pptx
@@ -3321,7 +3321,7 @@
                 </a:solidFill>
                 <a:latin typeface="Open Sans"/>
               </a:rPr>
-              <a:t>Semrush, US database, August 2026. Sorted by visits earned per ranking keyword.</a:t>
+              <a:t>Organic search footprint and domain authority across the vendor set the board asked about.</a:t>
             </a:r>
           </a:p>
         </p:txBody>
@@ -3379,7 +3379,7 @@
         <p:spPr>
           <a:xfrm>
             <a:off x="685800" y="1572768"/>
-            <a:ext cx="2926080" cy="329184"/>
+            <a:ext cx="3291840" cy="329184"/>
           </a:xfrm>
           <a:prstGeom prst="rect">
             <a:avLst/>
@@ -3420,8 +3420,8 @@
         </p:nvSpPr>
         <p:spPr>
           <a:xfrm>
-            <a:off x="3703320" y="1572768"/>
-            <a:ext cx="1600200" cy="329184"/>
+            <a:off x="4069080" y="1572768"/>
+            <a:ext cx="1828800" cy="329184"/>
           </a:xfrm>
           <a:prstGeom prst="rect">
             <a:avLst/>
@@ -3462,7 +3462,7 @@
         </p:nvSpPr>
         <p:spPr>
           <a:xfrm>
-            <a:off x="5349240" y="1572768"/>
+            <a:off x="5989320" y="1572768"/>
             <a:ext cx="1828800" cy="329184"/>
           </a:xfrm>
           <a:prstGeom prst="rect">
@@ -3504,8 +3504,8 @@
         </p:nvSpPr>
         <p:spPr>
           <a:xfrm>
-            <a:off x="7223760" y="1572768"/>
-            <a:ext cx="1783080" cy="329184"/>
+            <a:off x="7909560" y="1572768"/>
+            <a:ext cx="2011680" cy="329184"/>
           </a:xfrm>
           <a:prstGeom prst="rect">
             <a:avLst/>
@@ -3546,8 +3546,8 @@
         </p:nvSpPr>
         <p:spPr>
           <a:xfrm>
-            <a:off x="9034272" y="1572768"/>
-            <a:ext cx="1371600" cy="329184"/>
+            <a:off x="10012680" y="1572768"/>
+            <a:ext cx="1463040" cy="329184"/>
           </a:xfrm>
           <a:prstGeom prst="rect">
             <a:avLst/>
@@ -3575,48 +3575,6 @@
                 </a:solidFill>
                 <a:latin typeface="Open Sans"/>
               </a:rPr>
-              <a:t>Visits per Keyword</a:t>
-            </a:r>
-          </a:p>
-        </p:txBody>
-      </p:sp>
-      <p:sp>
-        <p:nvSpPr>
-          <p:cNvPr id="14" name="TextBox 13"/>
-          <p:cNvSpPr txBox="1"/>
-          <p:nvPr/>
-        </p:nvSpPr>
-        <p:spPr>
-          <a:xfrm>
-            <a:off x="10424160" y="1572768"/>
-            <a:ext cx="1188720" cy="329184"/>
-          </a:xfrm>
-          <a:prstGeom prst="rect">
-            <a:avLst/>
-          </a:prstGeom>
-          <a:noFill/>
-        </p:spPr>
-        <p:txBody>
-          <a:bodyPr wrap="square" lIns="0" rIns="0" tIns="0" bIns="0" anchor="t">
-            <a:spAutoFit/>
-          </a:bodyPr>
-          <a:lstStyle/>
-          <a:p>
-            <a:pPr algn="ctr">
-              <a:lnSpc>
-                <a:spcPct val="108000"/>
-              </a:lnSpc>
-              <a:spcAft>
-                <a:spcPts val="0"/>
-              </a:spcAft>
-            </a:pPr>
-            <a:r>
-              <a:rPr sz="950" b="1">
-                <a:solidFill>
-                  <a:srgbClr val="FFFFFF"/>
-                </a:solidFill>
-                <a:latin typeface="Open Sans"/>
-              </a:rPr>
               <a:t>Authority</a:t>
             </a:r>
           </a:p>
@@ -3624,7 +3582,7 @@
       </p:sp>
       <p:sp>
         <p:nvSpPr>
-          <p:cNvPr id="15" name="Rectangle 14"/>
+          <p:cNvPr id="14" name="Rectangle 13"/>
           <p:cNvSpPr/>
           <p:nvPr/>
         </p:nvSpPr>
@@ -3670,7 +3628,7 @@
       </p:sp>
       <p:sp>
         <p:nvSpPr>
-          <p:cNvPr id="16" name="Rectangle 15"/>
+          <p:cNvPr id="15" name="Rectangle 14"/>
           <p:cNvSpPr/>
           <p:nvPr/>
         </p:nvSpPr>
@@ -3714,14 +3672,14 @@
       </p:sp>
       <p:sp>
         <p:nvSpPr>
-          <p:cNvPr id="17" name="TextBox 16"/>
+          <p:cNvPr id="16" name="TextBox 15"/>
           <p:cNvSpPr txBox="1"/>
           <p:nvPr/>
         </p:nvSpPr>
         <p:spPr>
           <a:xfrm>
             <a:off x="685800" y="2139696"/>
-            <a:ext cx="2926080" cy="237744"/>
+            <a:ext cx="3291840" cy="237744"/>
           </a:xfrm>
           <a:prstGeom prst="rect">
             <a:avLst/>
@@ -3756,14 +3714,14 @@
       </p:sp>
       <p:sp>
         <p:nvSpPr>
-          <p:cNvPr id="18" name="TextBox 17"/>
+          <p:cNvPr id="17" name="TextBox 16"/>
           <p:cNvSpPr txBox="1"/>
           <p:nvPr/>
         </p:nvSpPr>
         <p:spPr>
           <a:xfrm>
-            <a:off x="3703320" y="2139696"/>
-            <a:ext cx="1600200" cy="237744"/>
+            <a:off x="4069080" y="2139696"/>
+            <a:ext cx="1828800" cy="237744"/>
           </a:xfrm>
           <a:prstGeom prst="rect">
             <a:avLst/>
@@ -3798,13 +3756,13 @@
       </p:sp>
       <p:sp>
         <p:nvSpPr>
-          <p:cNvPr id="19" name="TextBox 18"/>
+          <p:cNvPr id="18" name="TextBox 17"/>
           <p:cNvSpPr txBox="1"/>
           <p:nvPr/>
         </p:nvSpPr>
         <p:spPr>
           <a:xfrm>
-            <a:off x="5349240" y="2139696"/>
+            <a:off x="5989320" y="2139696"/>
             <a:ext cx="1828800" cy="237744"/>
           </a:xfrm>
           <a:prstGeom prst="rect">
@@ -3840,14 +3798,14 @@
       </p:sp>
       <p:sp>
         <p:nvSpPr>
-          <p:cNvPr id="20" name="TextBox 19"/>
+          <p:cNvPr id="19" name="TextBox 18"/>
           <p:cNvSpPr txBox="1"/>
           <p:nvPr/>
         </p:nvSpPr>
         <p:spPr>
           <a:xfrm>
-            <a:off x="7223760" y="2139696"/>
-            <a:ext cx="1783080" cy="237744"/>
+            <a:off x="7909560" y="2139696"/>
+            <a:ext cx="2011680" cy="237744"/>
           </a:xfrm>
           <a:prstGeom prst="rect">
             <a:avLst/>
@@ -3882,14 +3840,14 @@
       </p:sp>
       <p:sp>
         <p:nvSpPr>
-          <p:cNvPr id="21" name="TextBox 20"/>
+          <p:cNvPr id="20" name="TextBox 19"/>
           <p:cNvSpPr txBox="1"/>
           <p:nvPr/>
         </p:nvSpPr>
         <p:spPr>
           <a:xfrm>
-            <a:off x="9034272" y="2139696"/>
-            <a:ext cx="1371600" cy="237744"/>
+            <a:off x="10012680" y="2139696"/>
+            <a:ext cx="1463040" cy="237744"/>
           </a:xfrm>
           <a:prstGeom prst="rect">
             <a:avLst/>
@@ -3913,48 +3871,6 @@
             <a:r>
               <a:rPr sz="1150" b="1">
                 <a:solidFill>
-                  <a:srgbClr val="7A9905"/>
-                </a:solidFill>
-                <a:latin typeface="Open Sans"/>
-              </a:rPr>
-              <a:t>4.1</a:t>
-            </a:r>
-          </a:p>
-        </p:txBody>
-      </p:sp>
-      <p:sp>
-        <p:nvSpPr>
-          <p:cNvPr id="22" name="TextBox 21"/>
-          <p:cNvSpPr txBox="1"/>
-          <p:nvPr/>
-        </p:nvSpPr>
-        <p:spPr>
-          <a:xfrm>
-            <a:off x="10424160" y="2139696"/>
-            <a:ext cx="1188720" cy="237744"/>
-          </a:xfrm>
-          <a:prstGeom prst="rect">
-            <a:avLst/>
-          </a:prstGeom>
-          <a:noFill/>
-        </p:spPr>
-        <p:txBody>
-          <a:bodyPr wrap="square" lIns="0" rIns="0" tIns="0" bIns="0" anchor="t">
-            <a:spAutoFit/>
-          </a:bodyPr>
-          <a:lstStyle/>
-          <a:p>
-            <a:pPr algn="ctr">
-              <a:lnSpc>
-                <a:spcPct val="115000"/>
-              </a:lnSpc>
-              <a:spcAft>
-                <a:spcPts val="0"/>
-              </a:spcAft>
-            </a:pPr>
-            <a:r>
-              <a:rPr sz="1150" b="1">
-                <a:solidFill>
                   <a:srgbClr val="59257B"/>
                 </a:solidFill>
                 <a:latin typeface="Open Sans"/>
@@ -3966,7 +3882,7 @@
       </p:sp>
       <p:sp>
         <p:nvSpPr>
-          <p:cNvPr id="23" name="Rectangle 22"/>
+          <p:cNvPr id="21" name="Rectangle 20"/>
           <p:cNvSpPr/>
           <p:nvPr/>
         </p:nvSpPr>
@@ -4012,14 +3928,14 @@
       </p:sp>
       <p:sp>
         <p:nvSpPr>
-          <p:cNvPr id="24" name="TextBox 23"/>
+          <p:cNvPr id="22" name="TextBox 21"/>
           <p:cNvSpPr txBox="1"/>
           <p:nvPr/>
         </p:nvSpPr>
         <p:spPr>
           <a:xfrm>
             <a:off x="685800" y="2596896"/>
-            <a:ext cx="2926080" cy="237744"/>
+            <a:ext cx="3291840" cy="237744"/>
           </a:xfrm>
           <a:prstGeom prst="rect">
             <a:avLst/>
@@ -4047,21 +3963,21 @@
                 </a:solidFill>
                 <a:latin typeface="Open Sans"/>
               </a:rPr>
-              <a:t>Cohesity</a:t>
-            </a:r>
-          </a:p>
-        </p:txBody>
-      </p:sp>
-      <p:sp>
-        <p:nvSpPr>
-          <p:cNvPr id="25" name="TextBox 24"/>
+              <a:t>NetApp</a:t>
+            </a:r>
+          </a:p>
+        </p:txBody>
+      </p:sp>
+      <p:sp>
+        <p:nvSpPr>
+          <p:cNvPr id="23" name="TextBox 22"/>
           <p:cNvSpPr txBox="1"/>
           <p:nvPr/>
         </p:nvSpPr>
         <p:spPr>
           <a:xfrm>
-            <a:off x="3703320" y="2596896"/>
-            <a:ext cx="1600200" cy="237744"/>
+            <a:off x="4069080" y="2596896"/>
+            <a:ext cx="1828800" cy="237744"/>
           </a:xfrm>
           <a:prstGeom prst="rect">
             <a:avLst/>
@@ -4089,20 +4005,20 @@
                 </a:solidFill>
                 <a:latin typeface="Open Sans"/>
               </a:rPr>
-              <a:t>13,381</a:t>
-            </a:r>
-          </a:p>
-        </p:txBody>
-      </p:sp>
-      <p:sp>
-        <p:nvSpPr>
-          <p:cNvPr id="26" name="TextBox 25"/>
+              <a:t>39,118</a:t>
+            </a:r>
+          </a:p>
+        </p:txBody>
+      </p:sp>
+      <p:sp>
+        <p:nvSpPr>
+          <p:cNvPr id="24" name="TextBox 23"/>
           <p:cNvSpPr txBox="1"/>
           <p:nvPr/>
         </p:nvSpPr>
         <p:spPr>
           <a:xfrm>
-            <a:off x="5349240" y="2596896"/>
+            <a:off x="5989320" y="2596896"/>
             <a:ext cx="1828800" cy="237744"/>
           </a:xfrm>
           <a:prstGeom prst="rect">
@@ -4131,21 +4047,21 @@
                 </a:solidFill>
                 <a:latin typeface="Open Sans"/>
               </a:rPr>
-              <a:t>36,773</a:t>
-            </a:r>
-          </a:p>
-        </p:txBody>
-      </p:sp>
-      <p:sp>
-        <p:nvSpPr>
-          <p:cNvPr id="27" name="TextBox 26"/>
+              <a:t>75,742</a:t>
+            </a:r>
+          </a:p>
+        </p:txBody>
+      </p:sp>
+      <p:sp>
+        <p:nvSpPr>
+          <p:cNvPr id="25" name="TextBox 24"/>
           <p:cNvSpPr txBox="1"/>
           <p:nvPr/>
         </p:nvSpPr>
         <p:spPr>
           <a:xfrm>
-            <a:off x="7223760" y="2596896"/>
-            <a:ext cx="1783080" cy="237744"/>
+            <a:off x="7909560" y="2596896"/>
+            <a:ext cx="2011680" cy="237744"/>
           </a:xfrm>
           <a:prstGeom prst="rect">
             <a:avLst/>
@@ -4173,21 +4089,21 @@
                 </a:solidFill>
                 <a:latin typeface="Open Sans"/>
               </a:rPr>
-              <a:t>11,136</a:t>
-            </a:r>
-          </a:p>
-        </p:txBody>
-      </p:sp>
-      <p:sp>
-        <p:nvSpPr>
-          <p:cNvPr id="28" name="TextBox 27"/>
+              <a:t>32,473</a:t>
+            </a:r>
+          </a:p>
+        </p:txBody>
+      </p:sp>
+      <p:sp>
+        <p:nvSpPr>
+          <p:cNvPr id="26" name="TextBox 25"/>
           <p:cNvSpPr txBox="1"/>
           <p:nvPr/>
         </p:nvSpPr>
         <p:spPr>
           <a:xfrm>
-            <a:off x="9034272" y="2596896"/>
-            <a:ext cx="1371600" cy="237744"/>
+            <a:off x="10012680" y="2596896"/>
+            <a:ext cx="1463040" cy="237744"/>
           </a:xfrm>
           <a:prstGeom prst="rect">
             <a:avLst/>
@@ -4215,56 +4131,14 @@
                 </a:solidFill>
                 <a:latin typeface="Open Sans"/>
               </a:rPr>
-              <a:t>2.7</a:t>
-            </a:r>
-          </a:p>
-        </p:txBody>
-      </p:sp>
-      <p:sp>
-        <p:nvSpPr>
-          <p:cNvPr id="29" name="TextBox 28"/>
-          <p:cNvSpPr txBox="1"/>
-          <p:nvPr/>
-        </p:nvSpPr>
-        <p:spPr>
-          <a:xfrm>
-            <a:off x="10424160" y="2596896"/>
-            <a:ext cx="1188720" cy="237744"/>
-          </a:xfrm>
-          <a:prstGeom prst="rect">
-            <a:avLst/>
-          </a:prstGeom>
-          <a:noFill/>
-        </p:spPr>
-        <p:txBody>
-          <a:bodyPr wrap="square" lIns="0" rIns="0" tIns="0" bIns="0" anchor="t">
-            <a:spAutoFit/>
-          </a:bodyPr>
-          <a:lstStyle/>
-          <a:p>
-            <a:pPr algn="ctr">
-              <a:lnSpc>
-                <a:spcPct val="115000"/>
-              </a:lnSpc>
-              <a:spcAft>
-                <a:spcPts val="0"/>
-              </a:spcAft>
-            </a:pPr>
-            <a:r>
-              <a:rPr sz="1100" b="0">
-                <a:solidFill>
-                  <a:srgbClr val="595A5B"/>
-                </a:solidFill>
-                <a:latin typeface="Open Sans"/>
-              </a:rPr>
-              <a:t>43</a:t>
-            </a:r>
-          </a:p>
-        </p:txBody>
-      </p:sp>
-      <p:sp>
-        <p:nvSpPr>
-          <p:cNvPr id="30" name="Rectangle 29"/>
+              <a:t>51</a:t>
+            </a:r>
+          </a:p>
+        </p:txBody>
+      </p:sp>
+      <p:sp>
+        <p:nvSpPr>
+          <p:cNvPr id="27" name="Rectangle 26"/>
           <p:cNvSpPr/>
           <p:nvPr/>
         </p:nvSpPr>
@@ -4310,14 +4184,14 @@
       </p:sp>
       <p:sp>
         <p:nvSpPr>
-          <p:cNvPr id="31" name="TextBox 30"/>
+          <p:cNvPr id="28" name="TextBox 27"/>
           <p:cNvSpPr txBox="1"/>
           <p:nvPr/>
         </p:nvSpPr>
         <p:spPr>
           <a:xfrm>
             <a:off x="685800" y="3054096"/>
-            <a:ext cx="2926080" cy="237744"/>
+            <a:ext cx="3291840" cy="237744"/>
           </a:xfrm>
           <a:prstGeom prst="rect">
             <a:avLst/>
@@ -4352,14 +4226,14 @@
       </p:sp>
       <p:sp>
         <p:nvSpPr>
-          <p:cNvPr id="32" name="TextBox 31"/>
+          <p:cNvPr id="29" name="TextBox 28"/>
           <p:cNvSpPr txBox="1"/>
           <p:nvPr/>
         </p:nvSpPr>
         <p:spPr>
           <a:xfrm>
-            <a:off x="3703320" y="3054096"/>
-            <a:ext cx="1600200" cy="237744"/>
+            <a:off x="4069080" y="3054096"/>
+            <a:ext cx="1828800" cy="237744"/>
           </a:xfrm>
           <a:prstGeom prst="rect">
             <a:avLst/>
@@ -4394,13 +4268,13 @@
       </p:sp>
       <p:sp>
         <p:nvSpPr>
-          <p:cNvPr id="33" name="TextBox 32"/>
+          <p:cNvPr id="30" name="TextBox 29"/>
           <p:cNvSpPr txBox="1"/>
           <p:nvPr/>
         </p:nvSpPr>
         <p:spPr>
           <a:xfrm>
-            <a:off x="5349240" y="3054096"/>
+            <a:off x="5989320" y="3054096"/>
             <a:ext cx="1828800" cy="237744"/>
           </a:xfrm>
           <a:prstGeom prst="rect">
@@ -4436,14 +4310,14 @@
       </p:sp>
       <p:sp>
         <p:nvSpPr>
-          <p:cNvPr id="34" name="TextBox 33"/>
+          <p:cNvPr id="31" name="TextBox 30"/>
           <p:cNvSpPr txBox="1"/>
           <p:nvPr/>
         </p:nvSpPr>
         <p:spPr>
           <a:xfrm>
-            <a:off x="7223760" y="3054096"/>
-            <a:ext cx="1783080" cy="237744"/>
+            <a:off x="7909560" y="3054096"/>
+            <a:ext cx="2011680" cy="237744"/>
           </a:xfrm>
           <a:prstGeom prst="rect">
             <a:avLst/>
@@ -4478,14 +4352,14 @@
       </p:sp>
       <p:sp>
         <p:nvSpPr>
-          <p:cNvPr id="35" name="TextBox 34"/>
+          <p:cNvPr id="32" name="TextBox 31"/>
           <p:cNvSpPr txBox="1"/>
           <p:nvPr/>
         </p:nvSpPr>
         <p:spPr>
           <a:xfrm>
-            <a:off x="9034272" y="3054096"/>
-            <a:ext cx="1371600" cy="237744"/>
+            <a:off x="10012680" y="3054096"/>
+            <a:ext cx="1463040" cy="237744"/>
           </a:xfrm>
           <a:prstGeom prst="rect">
             <a:avLst/>
@@ -4513,48 +4387,6 @@
                 </a:solidFill>
                 <a:latin typeface="Open Sans"/>
               </a:rPr>
-              <a:t>2.1</a:t>
-            </a:r>
-          </a:p>
-        </p:txBody>
-      </p:sp>
-      <p:sp>
-        <p:nvSpPr>
-          <p:cNvPr id="36" name="TextBox 35"/>
-          <p:cNvSpPr txBox="1"/>
-          <p:nvPr/>
-        </p:nvSpPr>
-        <p:spPr>
-          <a:xfrm>
-            <a:off x="10424160" y="3054096"/>
-            <a:ext cx="1188720" cy="237744"/>
-          </a:xfrm>
-          <a:prstGeom prst="rect">
-            <a:avLst/>
-          </a:prstGeom>
-          <a:noFill/>
-        </p:spPr>
-        <p:txBody>
-          <a:bodyPr wrap="square" lIns="0" rIns="0" tIns="0" bIns="0" anchor="t">
-            <a:spAutoFit/>
-          </a:bodyPr>
-          <a:lstStyle/>
-          <a:p>
-            <a:pPr algn="ctr">
-              <a:lnSpc>
-                <a:spcPct val="115000"/>
-              </a:lnSpc>
-              <a:spcAft>
-                <a:spcPts val="0"/>
-              </a:spcAft>
-            </a:pPr>
-            <a:r>
-              <a:rPr sz="1100" b="0">
-                <a:solidFill>
-                  <a:srgbClr val="595A5B"/>
-                </a:solidFill>
-                <a:latin typeface="Open Sans"/>
-              </a:rPr>
               <a:t>51</a:t>
             </a:r>
           </a:p>
@@ -4562,7 +4394,7 @@
       </p:sp>
       <p:sp>
         <p:nvSpPr>
-          <p:cNvPr id="37" name="Rectangle 36"/>
+          <p:cNvPr id="33" name="Rectangle 32"/>
           <p:cNvSpPr/>
           <p:nvPr/>
         </p:nvSpPr>
@@ -4608,14 +4440,14 @@
       </p:sp>
       <p:sp>
         <p:nvSpPr>
-          <p:cNvPr id="38" name="TextBox 37"/>
+          <p:cNvPr id="34" name="TextBox 33"/>
           <p:cNvSpPr txBox="1"/>
           <p:nvPr/>
         </p:nvSpPr>
         <p:spPr>
           <a:xfrm>
             <a:off x="685800" y="3511296"/>
-            <a:ext cx="2926080" cy="237744"/>
+            <a:ext cx="3291840" cy="237744"/>
           </a:xfrm>
           <a:prstGeom prst="rect">
             <a:avLst/>
@@ -4643,21 +4475,21 @@
                 </a:solidFill>
                 <a:latin typeface="Open Sans"/>
               </a:rPr>
-              <a:t>NetApp</a:t>
-            </a:r>
-          </a:p>
-        </p:txBody>
-      </p:sp>
-      <p:sp>
-        <p:nvSpPr>
-          <p:cNvPr id="39" name="TextBox 38"/>
+              <a:t>Cohesity</a:t>
+            </a:r>
+          </a:p>
+        </p:txBody>
+      </p:sp>
+      <p:sp>
+        <p:nvSpPr>
+          <p:cNvPr id="35" name="TextBox 34"/>
           <p:cNvSpPr txBox="1"/>
           <p:nvPr/>
         </p:nvSpPr>
         <p:spPr>
           <a:xfrm>
-            <a:off x="3703320" y="3511296"/>
-            <a:ext cx="1600200" cy="237744"/>
+            <a:off x="4069080" y="3511296"/>
+            <a:ext cx="1828800" cy="237744"/>
           </a:xfrm>
           <a:prstGeom prst="rect">
             <a:avLst/>
@@ -4685,20 +4517,20 @@
                 </a:solidFill>
                 <a:latin typeface="Open Sans"/>
               </a:rPr>
-              <a:t>39,118</a:t>
-            </a:r>
-          </a:p>
-        </p:txBody>
-      </p:sp>
-      <p:sp>
-        <p:nvSpPr>
-          <p:cNvPr id="40" name="TextBox 39"/>
+              <a:t>13,381</a:t>
+            </a:r>
+          </a:p>
+        </p:txBody>
+      </p:sp>
+      <p:sp>
+        <p:nvSpPr>
+          <p:cNvPr id="36" name="TextBox 35"/>
           <p:cNvSpPr txBox="1"/>
           <p:nvPr/>
         </p:nvSpPr>
         <p:spPr>
           <a:xfrm>
-            <a:off x="5349240" y="3511296"/>
+            <a:off x="5989320" y="3511296"/>
             <a:ext cx="1828800" cy="237744"/>
           </a:xfrm>
           <a:prstGeom prst="rect">
@@ -4727,21 +4559,21 @@
                 </a:solidFill>
                 <a:latin typeface="Open Sans"/>
               </a:rPr>
-              <a:t>75,742</a:t>
-            </a:r>
-          </a:p>
-        </p:txBody>
-      </p:sp>
-      <p:sp>
-        <p:nvSpPr>
-          <p:cNvPr id="41" name="TextBox 40"/>
+              <a:t>36,773</a:t>
+            </a:r>
+          </a:p>
+        </p:txBody>
+      </p:sp>
+      <p:sp>
+        <p:nvSpPr>
+          <p:cNvPr id="37" name="TextBox 36"/>
           <p:cNvSpPr txBox="1"/>
           <p:nvPr/>
         </p:nvSpPr>
         <p:spPr>
           <a:xfrm>
-            <a:off x="7223760" y="3511296"/>
-            <a:ext cx="1783080" cy="237744"/>
+            <a:off x="7909560" y="3511296"/>
+            <a:ext cx="2011680" cy="237744"/>
           </a:xfrm>
           <a:prstGeom prst="rect">
             <a:avLst/>
@@ -4769,21 +4601,21 @@
                 </a:solidFill>
                 <a:latin typeface="Open Sans"/>
               </a:rPr>
-              <a:t>32,473</a:t>
-            </a:r>
-          </a:p>
-        </p:txBody>
-      </p:sp>
-      <p:sp>
-        <p:nvSpPr>
-          <p:cNvPr id="42" name="TextBox 41"/>
+              <a:t>11,136</a:t>
+            </a:r>
+          </a:p>
+        </p:txBody>
+      </p:sp>
+      <p:sp>
+        <p:nvSpPr>
+          <p:cNvPr id="38" name="TextBox 37"/>
           <p:cNvSpPr txBox="1"/>
           <p:nvPr/>
         </p:nvSpPr>
         <p:spPr>
           <a:xfrm>
-            <a:off x="9034272" y="3511296"/>
-            <a:ext cx="1371600" cy="237744"/>
+            <a:off x="10012680" y="3511296"/>
+            <a:ext cx="1463040" cy="237744"/>
           </a:xfrm>
           <a:prstGeom prst="rect">
             <a:avLst/>
@@ -4811,56 +4643,14 @@
                 </a:solidFill>
                 <a:latin typeface="Open Sans"/>
               </a:rPr>
-              <a:t>1.9</a:t>
-            </a:r>
-          </a:p>
-        </p:txBody>
-      </p:sp>
-      <p:sp>
-        <p:nvSpPr>
-          <p:cNvPr id="43" name="TextBox 42"/>
-          <p:cNvSpPr txBox="1"/>
-          <p:nvPr/>
-        </p:nvSpPr>
-        <p:spPr>
-          <a:xfrm>
-            <a:off x="10424160" y="3511296"/>
-            <a:ext cx="1188720" cy="237744"/>
-          </a:xfrm>
-          <a:prstGeom prst="rect">
-            <a:avLst/>
-          </a:prstGeom>
-          <a:noFill/>
-        </p:spPr>
-        <p:txBody>
-          <a:bodyPr wrap="square" lIns="0" rIns="0" tIns="0" bIns="0" anchor="t">
-            <a:spAutoFit/>
-          </a:bodyPr>
-          <a:lstStyle/>
-          <a:p>
-            <a:pPr algn="ctr">
-              <a:lnSpc>
-                <a:spcPct val="115000"/>
-              </a:lnSpc>
-              <a:spcAft>
-                <a:spcPts val="0"/>
-              </a:spcAft>
-            </a:pPr>
-            <a:r>
-              <a:rPr sz="1100" b="0">
-                <a:solidFill>
-                  <a:srgbClr val="595A5B"/>
-                </a:solidFill>
-                <a:latin typeface="Open Sans"/>
-              </a:rPr>
-              <a:t>51</a:t>
-            </a:r>
-          </a:p>
-        </p:txBody>
-      </p:sp>
-      <p:sp>
-        <p:nvSpPr>
-          <p:cNvPr id="44" name="Rectangle 43"/>
+              <a:t>43</a:t>
+            </a:r>
+          </a:p>
+        </p:txBody>
+      </p:sp>
+      <p:sp>
+        <p:nvSpPr>
+          <p:cNvPr id="39" name="Rectangle 38"/>
           <p:cNvSpPr/>
           <p:nvPr/>
         </p:nvSpPr>
@@ -4906,14 +4696,14 @@
       </p:sp>
       <p:sp>
         <p:nvSpPr>
-          <p:cNvPr id="45" name="TextBox 44"/>
+          <p:cNvPr id="40" name="TextBox 39"/>
           <p:cNvSpPr txBox="1"/>
           <p:nvPr/>
         </p:nvSpPr>
         <p:spPr>
           <a:xfrm>
             <a:off x="685800" y="3968496"/>
-            <a:ext cx="2926080" cy="237744"/>
+            <a:ext cx="3291840" cy="237744"/>
           </a:xfrm>
           <a:prstGeom prst="rect">
             <a:avLst/>
@@ -4948,14 +4738,14 @@
       </p:sp>
       <p:sp>
         <p:nvSpPr>
-          <p:cNvPr id="46" name="TextBox 45"/>
+          <p:cNvPr id="41" name="TextBox 40"/>
           <p:cNvSpPr txBox="1"/>
           <p:nvPr/>
         </p:nvSpPr>
         <p:spPr>
           <a:xfrm>
-            <a:off x="3703320" y="3968496"/>
-            <a:ext cx="1600200" cy="237744"/>
+            <a:off x="4069080" y="3968496"/>
+            <a:ext cx="1828800" cy="237744"/>
           </a:xfrm>
           <a:prstGeom prst="rect">
             <a:avLst/>
@@ -4990,13 +4780,13 @@
       </p:sp>
       <p:sp>
         <p:nvSpPr>
-          <p:cNvPr id="47" name="TextBox 46"/>
+          <p:cNvPr id="42" name="TextBox 41"/>
           <p:cNvSpPr txBox="1"/>
           <p:nvPr/>
         </p:nvSpPr>
         <p:spPr>
           <a:xfrm>
-            <a:off x="5349240" y="3968496"/>
+            <a:off x="5989320" y="3968496"/>
             <a:ext cx="1828800" cy="237744"/>
           </a:xfrm>
           <a:prstGeom prst="rect">
@@ -5032,14 +4822,14 @@
       </p:sp>
       <p:sp>
         <p:nvSpPr>
-          <p:cNvPr id="48" name="TextBox 47"/>
+          <p:cNvPr id="43" name="TextBox 42"/>
           <p:cNvSpPr txBox="1"/>
           <p:nvPr/>
         </p:nvSpPr>
         <p:spPr>
           <a:xfrm>
-            <a:off x="7223760" y="3968496"/>
-            <a:ext cx="1783080" cy="237744"/>
+            <a:off x="7909560" y="3968496"/>
+            <a:ext cx="2011680" cy="237744"/>
           </a:xfrm>
           <a:prstGeom prst="rect">
             <a:avLst/>
@@ -5074,14 +4864,14 @@
       </p:sp>
       <p:sp>
         <p:nvSpPr>
-          <p:cNvPr id="49" name="TextBox 48"/>
+          <p:cNvPr id="44" name="TextBox 43"/>
           <p:cNvSpPr txBox="1"/>
           <p:nvPr/>
         </p:nvSpPr>
         <p:spPr>
           <a:xfrm>
-            <a:off x="9034272" y="3968496"/>
-            <a:ext cx="1371600" cy="237744"/>
+            <a:off x="10012680" y="3968496"/>
+            <a:ext cx="1463040" cy="237744"/>
           </a:xfrm>
           <a:prstGeom prst="rect">
             <a:avLst/>
@@ -5109,21 +4899,21 @@
                 </a:solidFill>
                 <a:latin typeface="Open Sans"/>
               </a:rPr>
-              <a:t>1.8</a:t>
-            </a:r>
-          </a:p>
-        </p:txBody>
-      </p:sp>
-      <p:sp>
-        <p:nvSpPr>
-          <p:cNvPr id="50" name="TextBox 49"/>
+              <a:t>47</a:t>
+            </a:r>
+          </a:p>
+        </p:txBody>
+      </p:sp>
+      <p:sp>
+        <p:nvSpPr>
+          <p:cNvPr id="45" name="TextBox 44"/>
           <p:cNvSpPr txBox="1"/>
           <p:nvPr/>
         </p:nvSpPr>
         <p:spPr>
           <a:xfrm>
-            <a:off x="10424160" y="3968496"/>
-            <a:ext cx="1188720" cy="237744"/>
+            <a:off x="557784" y="4407408"/>
+            <a:ext cx="11064240" cy="219456"/>
           </a:xfrm>
           <a:prstGeom prst="rect">
             <a:avLst/>
@@ -5136,7 +4926,7 @@
           </a:bodyPr>
           <a:lstStyle/>
           <a:p>
-            <a:pPr algn="ctr">
+            <a:pPr algn="l">
               <a:lnSpc>
                 <a:spcPct val="115000"/>
               </a:lnSpc>
@@ -5145,27 +4935,27 @@
               </a:spcAft>
             </a:pPr>
             <a:r>
-              <a:rPr sz="1100" b="0">
-                <a:solidFill>
-                  <a:srgbClr val="595A5B"/>
+              <a:rPr sz="950" b="0">
+                <a:solidFill>
+                  <a:srgbClr val="8A8A8D"/>
                 </a:solidFill>
                 <a:latin typeface="Open Sans"/>
               </a:rPr>
-              <a:t>47</a:t>
-            </a:r>
-          </a:p>
-        </p:txBody>
-      </p:sp>
-      <p:sp>
-        <p:nvSpPr>
-          <p:cNvPr id="51" name="Rectangle 50"/>
+              <a:t>Source: Semrush, US database, snapshot of 15 August 2026. Authority is Semrush's 0 to 100 measure of overall domain strength.</a:t>
+            </a:r>
+          </a:p>
+        </p:txBody>
+      </p:sp>
+      <p:sp>
+        <p:nvSpPr>
+          <p:cNvPr id="46" name="Rectangle 45"/>
           <p:cNvSpPr/>
           <p:nvPr/>
         </p:nvSpPr>
         <p:spPr>
           <a:xfrm>
-            <a:off x="502920" y="4498848"/>
-            <a:ext cx="5504688" cy="1481328"/>
+            <a:off x="502920" y="4736592"/>
+            <a:ext cx="5504688" cy="1316736"/>
           </a:xfrm>
           <a:prstGeom prst="rect">
             <a:avLst/>
@@ -5204,14 +4994,14 @@
       </p:sp>
       <p:sp>
         <p:nvSpPr>
-          <p:cNvPr id="52" name="Rectangle 51"/>
+          <p:cNvPr id="47" name="Rectangle 46"/>
           <p:cNvSpPr/>
           <p:nvPr/>
         </p:nvSpPr>
         <p:spPr>
           <a:xfrm>
-            <a:off x="502920" y="4498848"/>
-            <a:ext cx="54864" cy="1481328"/>
+            <a:off x="502920" y="4736592"/>
+            <a:ext cx="54864" cy="1316736"/>
           </a:xfrm>
           <a:prstGeom prst="rect">
             <a:avLst/>
@@ -5248,14 +5038,14 @@
       </p:sp>
       <p:sp>
         <p:nvSpPr>
-          <p:cNvPr id="53" name="TextBox 52"/>
+          <p:cNvPr id="48" name="TextBox 47"/>
           <p:cNvSpPr txBox="1"/>
           <p:nvPr/>
         </p:nvSpPr>
         <p:spPr>
           <a:xfrm>
-            <a:off x="758952" y="4681728"/>
-            <a:ext cx="5074920" cy="1188720"/>
+            <a:off x="758952" y="4901184"/>
+            <a:ext cx="5074920" cy="1060704"/>
           </a:xfrm>
           <a:prstGeom prst="rect">
             <a:avLst/>
@@ -5273,7 +5063,7 @@
                 <a:spcPct val="115000"/>
               </a:lnSpc>
               <a:spcAft>
-                <a:spcPts val="600"/>
+                <a:spcPts val="500"/>
               </a:spcAft>
             </a:pPr>
             <a:r>
@@ -5289,34 +5079,34 @@
           <a:p>
             <a:pPr algn="l">
               <a:lnSpc>
-                <a:spcPct val="126000"/>
+                <a:spcPct val="124000"/>
               </a:lnSpc>
               <a:spcAft>
                 <a:spcPts val="0"/>
               </a:spcAft>
             </a:pPr>
             <a:r>
-              <a:rPr sz="1100" b="0">
+              <a:rPr sz="1050" b="0">
                 <a:solidFill>
                   <a:srgbClr val="595A5B"/>
                 </a:solidFill>
                 <a:latin typeface="Open Sans"/>
               </a:rPr>
-              <a:t>Komprise ranks for a sixth of NetApp's keywords and holds a third of its organic traffic. Every ranking keyword works harder here than at any vendor in the set, and the authority score matches Cohesity on a quarter of the referring domains.</a:t>
-            </a:r>
-          </a:p>
-        </p:txBody>
-      </p:sp>
-      <p:sp>
-        <p:nvSpPr>
-          <p:cNvPr id="54" name="Rectangle 53"/>
+              <a:t>Komprise ranks for a sixth of NetApp's keywords and holds a third of its traffic. Each keyword earns 4.1 visits against 1.9 for NetApp, and our authority matches Cohesity on a quarter of the referring domains.</a:t>
+            </a:r>
+          </a:p>
+        </p:txBody>
+      </p:sp>
+      <p:sp>
+        <p:nvSpPr>
+          <p:cNvPr id="49" name="Rectangle 48"/>
           <p:cNvSpPr/>
           <p:nvPr/>
         </p:nvSpPr>
         <p:spPr>
           <a:xfrm>
-            <a:off x="6181344" y="4498848"/>
-            <a:ext cx="5504688" cy="1481328"/>
+            <a:off x="6181344" y="4736592"/>
+            <a:ext cx="5504688" cy="1316736"/>
           </a:xfrm>
           <a:prstGeom prst="rect">
             <a:avLst/>
@@ -5355,14 +5145,14 @@
       </p:sp>
       <p:sp>
         <p:nvSpPr>
-          <p:cNvPr id="55" name="Rectangle 54"/>
+          <p:cNvPr id="50" name="Rectangle 49"/>
           <p:cNvSpPr/>
           <p:nvPr/>
         </p:nvSpPr>
         <p:spPr>
           <a:xfrm>
-            <a:off x="6181344" y="4498848"/>
-            <a:ext cx="54864" cy="1481328"/>
+            <a:off x="6181344" y="4736592"/>
+            <a:ext cx="54864" cy="1316736"/>
           </a:xfrm>
           <a:prstGeom prst="rect">
             <a:avLst/>
@@ -5399,14 +5189,14 @@
       </p:sp>
       <p:sp>
         <p:nvSpPr>
-          <p:cNvPr id="56" name="TextBox 55"/>
+          <p:cNvPr id="51" name="TextBox 50"/>
           <p:cNvSpPr txBox="1"/>
           <p:nvPr/>
         </p:nvSpPr>
         <p:spPr>
           <a:xfrm>
-            <a:off x="6437376" y="4681728"/>
-            <a:ext cx="5074920" cy="1188720"/>
+            <a:off x="6437376" y="4901184"/>
+            <a:ext cx="5074920" cy="1060704"/>
           </a:xfrm>
           <a:prstGeom prst="rect">
             <a:avLst/>
@@ -5424,7 +5214,7 @@
                 <a:spcPct val="115000"/>
               </a:lnSpc>
               <a:spcAft>
-                <a:spcPts val="600"/>
+                <a:spcPts val="500"/>
               </a:spcAft>
             </a:pPr>
             <a:r>
@@ -5440,14 +5230,14 @@
           <a:p>
             <a:pPr algn="l">
               <a:lnSpc>
-                <a:spcPct val="126000"/>
+                <a:spcPct val="124000"/>
               </a:lnSpc>
               <a:spcAft>
                 <a:spcPts val="0"/>
               </a:spcAft>
             </a:pPr>
             <a:r>
-              <a:rPr sz="1100" b="0">
+              <a:rPr sz="1050" b="0">
                 <a:solidFill>
                   <a:srgbClr val="595A5B"/>
                 </a:solidFill>
@@ -5460,14 +5250,14 @@
       </p:sp>
       <p:sp>
         <p:nvSpPr>
-          <p:cNvPr id="57" name="Rectangle 56"/>
+          <p:cNvPr id="52" name="Rectangle 51"/>
           <p:cNvSpPr/>
           <p:nvPr/>
         </p:nvSpPr>
         <p:spPr>
           <a:xfrm>
-            <a:off x="502920" y="6089904"/>
-            <a:ext cx="11183112" cy="438912"/>
+            <a:off x="502920" y="6144768"/>
+            <a:ext cx="11183112" cy="365760"/>
           </a:xfrm>
           <a:prstGeom prst="rect">
             <a:avLst/>
@@ -5504,14 +5294,14 @@
       </p:sp>
       <p:sp>
         <p:nvSpPr>
-          <p:cNvPr id="58" name="Rectangle 57"/>
+          <p:cNvPr id="53" name="Rectangle 52"/>
           <p:cNvSpPr/>
           <p:nvPr/>
         </p:nvSpPr>
         <p:spPr>
           <a:xfrm>
-            <a:off x="502920" y="6089904"/>
-            <a:ext cx="54864" cy="438912"/>
+            <a:off x="502920" y="6144768"/>
+            <a:ext cx="54864" cy="365760"/>
           </a:xfrm>
           <a:prstGeom prst="rect">
             <a:avLst/>
@@ -5548,14 +5338,14 @@
       </p:sp>
       <p:sp>
         <p:nvSpPr>
-          <p:cNvPr id="59" name="TextBox 58"/>
+          <p:cNvPr id="54" name="TextBox 53"/>
           <p:cNvSpPr txBox="1"/>
           <p:nvPr/>
         </p:nvSpPr>
         <p:spPr>
           <a:xfrm>
-            <a:off x="758952" y="6199632"/>
-            <a:ext cx="10789920" cy="274320"/>
+            <a:off x="758952" y="6227064"/>
+            <a:ext cx="10789920" cy="237744"/>
           </a:xfrm>
           <a:prstGeom prst="rect">
             <a:avLst/>
@@ -5577,7 +5367,7 @@
               </a:spcAft>
             </a:pPr>
             <a:r>
-              <a:rPr sz="1100" b="1">
+              <a:rPr sz="1050" b="1">
                 <a:solidFill>
                   <a:srgbClr val="59257B"/>
                 </a:solidFill>
@@ -5590,7 +5380,7 @@
       </p:sp>
       <p:sp>
         <p:nvSpPr>
-          <p:cNvPr id="60" name="TextBox 59"/>
+          <p:cNvPr id="55" name="TextBox 54"/>
           <p:cNvSpPr txBox="1"/>
           <p:nvPr/>
         </p:nvSpPr>
@@ -5632,7 +5422,7 @@
       </p:sp>
       <p:sp>
         <p:nvSpPr>
-          <p:cNvPr id="61" name="TextBox 60"/>
+          <p:cNvPr id="56" name="TextBox 55"/>
           <p:cNvSpPr txBox="1"/>
           <p:nvPr/>
         </p:nvSpPr>

</xml_diff>

<commit_message>
Add indexed pages column and label traffic as a modelled estimate
- Add Pages Indexed from Google site: queries, with the estimate and subdomain
  caveats stated in the on-slide source line.
- Rename the traffic column to "Est. Monthly Traffic" and state on the slide that
  it is a Semrush model rather than measured clicks.
- Rewrite the left read-out to rest on keyword and page counts instead of the
  estimated traffic figure.

Search Console reports roughly 4.6k monthly clicks for komprise.com against
Semrush's 25,126, an overstatement of about five times. The column stays on
Semrush for all five vendors because Search Console covers only owned
properties, and mixing the two would understate Komprise by that same factor.
SOURCES.md records this, and flags that the Q2 board deck quotes the same series
as measured visits.

Co-Authored-By: Claude Opus 5 <noreply@anthropic.com>
Claude-Session: https://claude.ai/code/session_01Qb9Qq8GcnmrwCpYXA3jWR9
</commit_message>
<xml_diff>
--- a/Komprise_Vendor_Comparison_Sep2026.pptx
+++ b/Komprise_Vendor_Comparison_Sep2026.pptx
@@ -3379,7 +3379,7 @@
         <p:spPr>
           <a:xfrm>
             <a:off x="685800" y="1572768"/>
-            <a:ext cx="3291840" cy="329184"/>
+            <a:ext cx="2697480" cy="329184"/>
           </a:xfrm>
           <a:prstGeom prst="rect">
             <a:avLst/>
@@ -3420,8 +3420,8 @@
         </p:nvSpPr>
         <p:spPr>
           <a:xfrm>
-            <a:off x="4069080" y="1572768"/>
-            <a:ext cx="1828800" cy="329184"/>
+            <a:off x="3474720" y="1572768"/>
+            <a:ext cx="1554480" cy="329184"/>
           </a:xfrm>
           <a:prstGeom prst="rect">
             <a:avLst/>
@@ -3462,8 +3462,8 @@
         </p:nvSpPr>
         <p:spPr>
           <a:xfrm>
-            <a:off x="5989320" y="1572768"/>
-            <a:ext cx="1828800" cy="329184"/>
+            <a:off x="5074920" y="1572768"/>
+            <a:ext cx="1463040" cy="329184"/>
           </a:xfrm>
           <a:prstGeom prst="rect">
             <a:avLst/>
@@ -3491,7 +3491,7 @@
                 </a:solidFill>
                 <a:latin typeface="Open Sans"/>
               </a:rPr>
-              <a:t>Monthly Traffic</a:t>
+              <a:t>Pages Indexed</a:t>
             </a:r>
           </a:p>
         </p:txBody>
@@ -3504,8 +3504,8 @@
         </p:nvSpPr>
         <p:spPr>
           <a:xfrm>
-            <a:off x="7909560" y="1572768"/>
-            <a:ext cx="2011680" cy="329184"/>
+            <a:off x="6583680" y="1572768"/>
+            <a:ext cx="1554480" cy="329184"/>
           </a:xfrm>
           <a:prstGeom prst="rect">
             <a:avLst/>
@@ -3533,7 +3533,7 @@
                 </a:solidFill>
                 <a:latin typeface="Open Sans"/>
               </a:rPr>
-              <a:t>Keywords in AI Answers</a:t>
+              <a:t>Est. Monthly Traffic</a:t>
             </a:r>
           </a:p>
         </p:txBody>
@@ -3546,8 +3546,8 @@
         </p:nvSpPr>
         <p:spPr>
           <a:xfrm>
-            <a:off x="10012680" y="1572768"/>
-            <a:ext cx="1463040" cy="329184"/>
+            <a:off x="8183879" y="1572768"/>
+            <a:ext cx="1965960" cy="329184"/>
           </a:xfrm>
           <a:prstGeom prst="rect">
             <a:avLst/>
@@ -3575,6 +3575,48 @@
                 </a:solidFill>
                 <a:latin typeface="Open Sans"/>
               </a:rPr>
+              <a:t>Keywords in AI Answers</a:t>
+            </a:r>
+          </a:p>
+        </p:txBody>
+      </p:sp>
+      <p:sp>
+        <p:nvSpPr>
+          <p:cNvPr id="14" name="TextBox 13"/>
+          <p:cNvSpPr txBox="1"/>
+          <p:nvPr/>
+        </p:nvSpPr>
+        <p:spPr>
+          <a:xfrm>
+            <a:off x="10195560" y="1572768"/>
+            <a:ext cx="1280160" cy="329184"/>
+          </a:xfrm>
+          <a:prstGeom prst="rect">
+            <a:avLst/>
+          </a:prstGeom>
+          <a:noFill/>
+        </p:spPr>
+        <p:txBody>
+          <a:bodyPr wrap="square" lIns="0" rIns="0" tIns="0" bIns="0" anchor="t">
+            <a:spAutoFit/>
+          </a:bodyPr>
+          <a:lstStyle/>
+          <a:p>
+            <a:pPr algn="ctr">
+              <a:lnSpc>
+                <a:spcPct val="108000"/>
+              </a:lnSpc>
+              <a:spcAft>
+                <a:spcPts val="0"/>
+              </a:spcAft>
+            </a:pPr>
+            <a:r>
+              <a:rPr sz="950" b="1">
+                <a:solidFill>
+                  <a:srgbClr val="FFFFFF"/>
+                </a:solidFill>
+                <a:latin typeface="Open Sans"/>
+              </a:rPr>
               <a:t>Authority</a:t>
             </a:r>
           </a:p>
@@ -3582,7 +3624,7 @@
       </p:sp>
       <p:sp>
         <p:nvSpPr>
-          <p:cNvPr id="14" name="Rectangle 13"/>
+          <p:cNvPr id="15" name="Rectangle 14"/>
           <p:cNvSpPr/>
           <p:nvPr/>
         </p:nvSpPr>
@@ -3628,7 +3670,7 @@
       </p:sp>
       <p:sp>
         <p:nvSpPr>
-          <p:cNvPr id="15" name="Rectangle 14"/>
+          <p:cNvPr id="16" name="Rectangle 15"/>
           <p:cNvSpPr/>
           <p:nvPr/>
         </p:nvSpPr>
@@ -3672,14 +3714,14 @@
       </p:sp>
       <p:sp>
         <p:nvSpPr>
-          <p:cNvPr id="16" name="TextBox 15"/>
+          <p:cNvPr id="17" name="TextBox 16"/>
           <p:cNvSpPr txBox="1"/>
           <p:nvPr/>
         </p:nvSpPr>
         <p:spPr>
           <a:xfrm>
             <a:off x="685800" y="2139696"/>
-            <a:ext cx="3291840" cy="237744"/>
+            <a:ext cx="2697480" cy="237744"/>
           </a:xfrm>
           <a:prstGeom prst="rect">
             <a:avLst/>
@@ -3714,14 +3756,14 @@
       </p:sp>
       <p:sp>
         <p:nvSpPr>
-          <p:cNvPr id="17" name="TextBox 16"/>
+          <p:cNvPr id="18" name="TextBox 17"/>
           <p:cNvSpPr txBox="1"/>
           <p:nvPr/>
         </p:nvSpPr>
         <p:spPr>
           <a:xfrm>
-            <a:off x="4069080" y="2139696"/>
-            <a:ext cx="1828800" cy="237744"/>
+            <a:off x="3474720" y="2139696"/>
+            <a:ext cx="1554480" cy="237744"/>
           </a:xfrm>
           <a:prstGeom prst="rect">
             <a:avLst/>
@@ -3756,14 +3798,14 @@
       </p:sp>
       <p:sp>
         <p:nvSpPr>
-          <p:cNvPr id="18" name="TextBox 17"/>
+          <p:cNvPr id="19" name="TextBox 18"/>
           <p:cNvSpPr txBox="1"/>
           <p:nvPr/>
         </p:nvSpPr>
         <p:spPr>
           <a:xfrm>
-            <a:off x="5989320" y="2139696"/>
-            <a:ext cx="1828800" cy="237744"/>
+            <a:off x="5074920" y="2139696"/>
+            <a:ext cx="1463040" cy="237744"/>
           </a:xfrm>
           <a:prstGeom prst="rect">
             <a:avLst/>
@@ -3791,21 +3833,21 @@
                 </a:solidFill>
                 <a:latin typeface="Open Sans"/>
               </a:rPr>
-              <a:t>25,126</a:t>
-            </a:r>
-          </a:p>
-        </p:txBody>
-      </p:sp>
-      <p:sp>
-        <p:nvSpPr>
-          <p:cNvPr id="19" name="TextBox 18"/>
+              <a:t>1,610</a:t>
+            </a:r>
+          </a:p>
+        </p:txBody>
+      </p:sp>
+      <p:sp>
+        <p:nvSpPr>
+          <p:cNvPr id="20" name="TextBox 19"/>
           <p:cNvSpPr txBox="1"/>
           <p:nvPr/>
         </p:nvSpPr>
         <p:spPr>
           <a:xfrm>
-            <a:off x="7909560" y="2139696"/>
-            <a:ext cx="2011680" cy="237744"/>
+            <a:off x="6583680" y="2139696"/>
+            <a:ext cx="1554480" cy="237744"/>
           </a:xfrm>
           <a:prstGeom prst="rect">
             <a:avLst/>
@@ -3833,21 +3875,21 @@
                 </a:solidFill>
                 <a:latin typeface="Open Sans"/>
               </a:rPr>
-              <a:t>5,464</a:t>
-            </a:r>
-          </a:p>
-        </p:txBody>
-      </p:sp>
-      <p:sp>
-        <p:nvSpPr>
-          <p:cNvPr id="20" name="TextBox 19"/>
+              <a:t>25,126</a:t>
+            </a:r>
+          </a:p>
+        </p:txBody>
+      </p:sp>
+      <p:sp>
+        <p:nvSpPr>
+          <p:cNvPr id="21" name="TextBox 20"/>
           <p:cNvSpPr txBox="1"/>
           <p:nvPr/>
         </p:nvSpPr>
         <p:spPr>
           <a:xfrm>
-            <a:off x="10012680" y="2139696"/>
-            <a:ext cx="1463040" cy="237744"/>
+            <a:off x="8183879" y="2139696"/>
+            <a:ext cx="1965960" cy="237744"/>
           </a:xfrm>
           <a:prstGeom prst="rect">
             <a:avLst/>
@@ -3875,6 +3917,48 @@
                 </a:solidFill>
                 <a:latin typeface="Open Sans"/>
               </a:rPr>
+              <a:t>5,464</a:t>
+            </a:r>
+          </a:p>
+        </p:txBody>
+      </p:sp>
+      <p:sp>
+        <p:nvSpPr>
+          <p:cNvPr id="22" name="TextBox 21"/>
+          <p:cNvSpPr txBox="1"/>
+          <p:nvPr/>
+        </p:nvSpPr>
+        <p:spPr>
+          <a:xfrm>
+            <a:off x="10195560" y="2139696"/>
+            <a:ext cx="1280160" cy="237744"/>
+          </a:xfrm>
+          <a:prstGeom prst="rect">
+            <a:avLst/>
+          </a:prstGeom>
+          <a:noFill/>
+        </p:spPr>
+        <p:txBody>
+          <a:bodyPr wrap="square" lIns="0" rIns="0" tIns="0" bIns="0" anchor="t">
+            <a:spAutoFit/>
+          </a:bodyPr>
+          <a:lstStyle/>
+          <a:p>
+            <a:pPr algn="ctr">
+              <a:lnSpc>
+                <a:spcPct val="115000"/>
+              </a:lnSpc>
+              <a:spcAft>
+                <a:spcPts val="0"/>
+              </a:spcAft>
+            </a:pPr>
+            <a:r>
+              <a:rPr sz="1150" b="1">
+                <a:solidFill>
+                  <a:srgbClr val="59257B"/>
+                </a:solidFill>
+                <a:latin typeface="Open Sans"/>
+              </a:rPr>
               <a:t>43</a:t>
             </a:r>
           </a:p>
@@ -3882,7 +3966,7 @@
       </p:sp>
       <p:sp>
         <p:nvSpPr>
-          <p:cNvPr id="21" name="Rectangle 20"/>
+          <p:cNvPr id="23" name="Rectangle 22"/>
           <p:cNvSpPr/>
           <p:nvPr/>
         </p:nvSpPr>
@@ -3928,14 +4012,14 @@
       </p:sp>
       <p:sp>
         <p:nvSpPr>
-          <p:cNvPr id="22" name="TextBox 21"/>
+          <p:cNvPr id="24" name="TextBox 23"/>
           <p:cNvSpPr txBox="1"/>
           <p:nvPr/>
         </p:nvSpPr>
         <p:spPr>
           <a:xfrm>
             <a:off x="685800" y="2596896"/>
-            <a:ext cx="3291840" cy="237744"/>
+            <a:ext cx="2697480" cy="237744"/>
           </a:xfrm>
           <a:prstGeom prst="rect">
             <a:avLst/>
@@ -3970,14 +4054,14 @@
       </p:sp>
       <p:sp>
         <p:nvSpPr>
-          <p:cNvPr id="23" name="TextBox 22"/>
+          <p:cNvPr id="25" name="TextBox 24"/>
           <p:cNvSpPr txBox="1"/>
           <p:nvPr/>
         </p:nvSpPr>
         <p:spPr>
           <a:xfrm>
-            <a:off x="4069080" y="2596896"/>
-            <a:ext cx="1828800" cy="237744"/>
+            <a:off x="3474720" y="2596896"/>
+            <a:ext cx="1554480" cy="237744"/>
           </a:xfrm>
           <a:prstGeom prst="rect">
             <a:avLst/>
@@ -4012,14 +4096,14 @@
       </p:sp>
       <p:sp>
         <p:nvSpPr>
-          <p:cNvPr id="24" name="TextBox 23"/>
+          <p:cNvPr id="26" name="TextBox 25"/>
           <p:cNvSpPr txBox="1"/>
           <p:nvPr/>
         </p:nvSpPr>
         <p:spPr>
           <a:xfrm>
-            <a:off x="5989320" y="2596896"/>
-            <a:ext cx="1828800" cy="237744"/>
+            <a:off x="5074920" y="2596896"/>
+            <a:ext cx="1463040" cy="237744"/>
           </a:xfrm>
           <a:prstGeom prst="rect">
             <a:avLst/>
@@ -4047,21 +4131,21 @@
                 </a:solidFill>
                 <a:latin typeface="Open Sans"/>
               </a:rPr>
-              <a:t>75,742</a:t>
-            </a:r>
-          </a:p>
-        </p:txBody>
-      </p:sp>
-      <p:sp>
-        <p:nvSpPr>
-          <p:cNvPr id="25" name="TextBox 24"/>
+              <a:t>621,000</a:t>
+            </a:r>
+          </a:p>
+        </p:txBody>
+      </p:sp>
+      <p:sp>
+        <p:nvSpPr>
+          <p:cNvPr id="27" name="TextBox 26"/>
           <p:cNvSpPr txBox="1"/>
           <p:nvPr/>
         </p:nvSpPr>
         <p:spPr>
           <a:xfrm>
-            <a:off x="7909560" y="2596896"/>
-            <a:ext cx="2011680" cy="237744"/>
+            <a:off x="6583680" y="2596896"/>
+            <a:ext cx="1554480" cy="237744"/>
           </a:xfrm>
           <a:prstGeom prst="rect">
             <a:avLst/>
@@ -4089,21 +4173,21 @@
                 </a:solidFill>
                 <a:latin typeface="Open Sans"/>
               </a:rPr>
-              <a:t>32,473</a:t>
-            </a:r>
-          </a:p>
-        </p:txBody>
-      </p:sp>
-      <p:sp>
-        <p:nvSpPr>
-          <p:cNvPr id="26" name="TextBox 25"/>
+              <a:t>75,742</a:t>
+            </a:r>
+          </a:p>
+        </p:txBody>
+      </p:sp>
+      <p:sp>
+        <p:nvSpPr>
+          <p:cNvPr id="28" name="TextBox 27"/>
           <p:cNvSpPr txBox="1"/>
           <p:nvPr/>
         </p:nvSpPr>
         <p:spPr>
           <a:xfrm>
-            <a:off x="10012680" y="2596896"/>
-            <a:ext cx="1463040" cy="237744"/>
+            <a:off x="8183879" y="2596896"/>
+            <a:ext cx="1965960" cy="237744"/>
           </a:xfrm>
           <a:prstGeom prst="rect">
             <a:avLst/>
@@ -4131,6 +4215,48 @@
                 </a:solidFill>
                 <a:latin typeface="Open Sans"/>
               </a:rPr>
+              <a:t>32,473</a:t>
+            </a:r>
+          </a:p>
+        </p:txBody>
+      </p:sp>
+      <p:sp>
+        <p:nvSpPr>
+          <p:cNvPr id="29" name="TextBox 28"/>
+          <p:cNvSpPr txBox="1"/>
+          <p:nvPr/>
+        </p:nvSpPr>
+        <p:spPr>
+          <a:xfrm>
+            <a:off x="10195560" y="2596896"/>
+            <a:ext cx="1280160" cy="237744"/>
+          </a:xfrm>
+          <a:prstGeom prst="rect">
+            <a:avLst/>
+          </a:prstGeom>
+          <a:noFill/>
+        </p:spPr>
+        <p:txBody>
+          <a:bodyPr wrap="square" lIns="0" rIns="0" tIns="0" bIns="0" anchor="t">
+            <a:spAutoFit/>
+          </a:bodyPr>
+          <a:lstStyle/>
+          <a:p>
+            <a:pPr algn="ctr">
+              <a:lnSpc>
+                <a:spcPct val="115000"/>
+              </a:lnSpc>
+              <a:spcAft>
+                <a:spcPts val="0"/>
+              </a:spcAft>
+            </a:pPr>
+            <a:r>
+              <a:rPr sz="1100" b="0">
+                <a:solidFill>
+                  <a:srgbClr val="595A5B"/>
+                </a:solidFill>
+                <a:latin typeface="Open Sans"/>
+              </a:rPr>
               <a:t>51</a:t>
             </a:r>
           </a:p>
@@ -4138,7 +4264,7 @@
       </p:sp>
       <p:sp>
         <p:nvSpPr>
-          <p:cNvPr id="27" name="Rectangle 26"/>
+          <p:cNvPr id="30" name="Rectangle 29"/>
           <p:cNvSpPr/>
           <p:nvPr/>
         </p:nvSpPr>
@@ -4184,14 +4310,14 @@
       </p:sp>
       <p:sp>
         <p:nvSpPr>
-          <p:cNvPr id="28" name="TextBox 27"/>
+          <p:cNvPr id="31" name="TextBox 30"/>
           <p:cNvSpPr txBox="1"/>
           <p:nvPr/>
         </p:nvSpPr>
         <p:spPr>
           <a:xfrm>
             <a:off x="685800" y="3054096"/>
-            <a:ext cx="3291840" cy="237744"/>
+            <a:ext cx="2697480" cy="237744"/>
           </a:xfrm>
           <a:prstGeom prst="rect">
             <a:avLst/>
@@ -4226,14 +4352,14 @@
       </p:sp>
       <p:sp>
         <p:nvSpPr>
-          <p:cNvPr id="29" name="TextBox 28"/>
+          <p:cNvPr id="32" name="TextBox 31"/>
           <p:cNvSpPr txBox="1"/>
           <p:nvPr/>
         </p:nvSpPr>
         <p:spPr>
           <a:xfrm>
-            <a:off x="4069080" y="3054096"/>
-            <a:ext cx="1828800" cy="237744"/>
+            <a:off x="3474720" y="3054096"/>
+            <a:ext cx="1554480" cy="237744"/>
           </a:xfrm>
           <a:prstGeom prst="rect">
             <a:avLst/>
@@ -4268,14 +4394,14 @@
       </p:sp>
       <p:sp>
         <p:nvSpPr>
-          <p:cNvPr id="30" name="TextBox 29"/>
+          <p:cNvPr id="33" name="TextBox 32"/>
           <p:cNvSpPr txBox="1"/>
           <p:nvPr/>
         </p:nvSpPr>
         <p:spPr>
           <a:xfrm>
-            <a:off x="5989320" y="3054096"/>
-            <a:ext cx="1828800" cy="237744"/>
+            <a:off x="5074920" y="3054096"/>
+            <a:ext cx="1463040" cy="237744"/>
           </a:xfrm>
           <a:prstGeom prst="rect">
             <a:avLst/>
@@ -4303,21 +4429,21 @@
                 </a:solidFill>
                 <a:latin typeface="Open Sans"/>
               </a:rPr>
-              <a:t>42,990</a:t>
-            </a:r>
-          </a:p>
-        </p:txBody>
-      </p:sp>
-      <p:sp>
-        <p:nvSpPr>
-          <p:cNvPr id="31" name="TextBox 30"/>
+              <a:t>32,900</a:t>
+            </a:r>
+          </a:p>
+        </p:txBody>
+      </p:sp>
+      <p:sp>
+        <p:nvSpPr>
+          <p:cNvPr id="34" name="TextBox 33"/>
           <p:cNvSpPr txBox="1"/>
           <p:nvPr/>
         </p:nvSpPr>
         <p:spPr>
           <a:xfrm>
-            <a:off x="7909560" y="3054096"/>
-            <a:ext cx="2011680" cy="237744"/>
+            <a:off x="6583680" y="3054096"/>
+            <a:ext cx="1554480" cy="237744"/>
           </a:xfrm>
           <a:prstGeom prst="rect">
             <a:avLst/>
@@ -4345,21 +4471,21 @@
                 </a:solidFill>
                 <a:latin typeface="Open Sans"/>
               </a:rPr>
-              <a:t>17,968</a:t>
-            </a:r>
-          </a:p>
-        </p:txBody>
-      </p:sp>
-      <p:sp>
-        <p:nvSpPr>
-          <p:cNvPr id="32" name="TextBox 31"/>
+              <a:t>42,990</a:t>
+            </a:r>
+          </a:p>
+        </p:txBody>
+      </p:sp>
+      <p:sp>
+        <p:nvSpPr>
+          <p:cNvPr id="35" name="TextBox 34"/>
           <p:cNvSpPr txBox="1"/>
           <p:nvPr/>
         </p:nvSpPr>
         <p:spPr>
           <a:xfrm>
-            <a:off x="10012680" y="3054096"/>
-            <a:ext cx="1463040" cy="237744"/>
+            <a:off x="8183879" y="3054096"/>
+            <a:ext cx="1965960" cy="237744"/>
           </a:xfrm>
           <a:prstGeom prst="rect">
             <a:avLst/>
@@ -4387,6 +4513,48 @@
                 </a:solidFill>
                 <a:latin typeface="Open Sans"/>
               </a:rPr>
+              <a:t>17,968</a:t>
+            </a:r>
+          </a:p>
+        </p:txBody>
+      </p:sp>
+      <p:sp>
+        <p:nvSpPr>
+          <p:cNvPr id="36" name="TextBox 35"/>
+          <p:cNvSpPr txBox="1"/>
+          <p:nvPr/>
+        </p:nvSpPr>
+        <p:spPr>
+          <a:xfrm>
+            <a:off x="10195560" y="3054096"/>
+            <a:ext cx="1280160" cy="237744"/>
+          </a:xfrm>
+          <a:prstGeom prst="rect">
+            <a:avLst/>
+          </a:prstGeom>
+          <a:noFill/>
+        </p:spPr>
+        <p:txBody>
+          <a:bodyPr wrap="square" lIns="0" rIns="0" tIns="0" bIns="0" anchor="t">
+            <a:spAutoFit/>
+          </a:bodyPr>
+          <a:lstStyle/>
+          <a:p>
+            <a:pPr algn="ctr">
+              <a:lnSpc>
+                <a:spcPct val="115000"/>
+              </a:lnSpc>
+              <a:spcAft>
+                <a:spcPts val="0"/>
+              </a:spcAft>
+            </a:pPr>
+            <a:r>
+              <a:rPr sz="1100" b="0">
+                <a:solidFill>
+                  <a:srgbClr val="595A5B"/>
+                </a:solidFill>
+                <a:latin typeface="Open Sans"/>
+              </a:rPr>
               <a:t>51</a:t>
             </a:r>
           </a:p>
@@ -4394,7 +4562,7 @@
       </p:sp>
       <p:sp>
         <p:nvSpPr>
-          <p:cNvPr id="33" name="Rectangle 32"/>
+          <p:cNvPr id="37" name="Rectangle 36"/>
           <p:cNvSpPr/>
           <p:nvPr/>
         </p:nvSpPr>
@@ -4440,14 +4608,14 @@
       </p:sp>
       <p:sp>
         <p:nvSpPr>
-          <p:cNvPr id="34" name="TextBox 33"/>
+          <p:cNvPr id="38" name="TextBox 37"/>
           <p:cNvSpPr txBox="1"/>
           <p:nvPr/>
         </p:nvSpPr>
         <p:spPr>
           <a:xfrm>
             <a:off x="685800" y="3511296"/>
-            <a:ext cx="3291840" cy="237744"/>
+            <a:ext cx="2697480" cy="237744"/>
           </a:xfrm>
           <a:prstGeom prst="rect">
             <a:avLst/>
@@ -4482,14 +4650,14 @@
       </p:sp>
       <p:sp>
         <p:nvSpPr>
-          <p:cNvPr id="35" name="TextBox 34"/>
+          <p:cNvPr id="39" name="TextBox 38"/>
           <p:cNvSpPr txBox="1"/>
           <p:nvPr/>
         </p:nvSpPr>
         <p:spPr>
           <a:xfrm>
-            <a:off x="4069080" y="3511296"/>
-            <a:ext cx="1828800" cy="237744"/>
+            <a:off x="3474720" y="3511296"/>
+            <a:ext cx="1554480" cy="237744"/>
           </a:xfrm>
           <a:prstGeom prst="rect">
             <a:avLst/>
@@ -4524,14 +4692,14 @@
       </p:sp>
       <p:sp>
         <p:nvSpPr>
-          <p:cNvPr id="36" name="TextBox 35"/>
+          <p:cNvPr id="40" name="TextBox 39"/>
           <p:cNvSpPr txBox="1"/>
           <p:nvPr/>
         </p:nvSpPr>
         <p:spPr>
           <a:xfrm>
-            <a:off x="5989320" y="3511296"/>
-            <a:ext cx="1828800" cy="237744"/>
+            <a:off x="5074920" y="3511296"/>
+            <a:ext cx="1463040" cy="237744"/>
           </a:xfrm>
           <a:prstGeom prst="rect">
             <a:avLst/>
@@ -4559,21 +4727,21 @@
                 </a:solidFill>
                 <a:latin typeface="Open Sans"/>
               </a:rPr>
-              <a:t>36,773</a:t>
-            </a:r>
-          </a:p>
-        </p:txBody>
-      </p:sp>
-      <p:sp>
-        <p:nvSpPr>
-          <p:cNvPr id="37" name="TextBox 36"/>
+              <a:t>310,000</a:t>
+            </a:r>
+          </a:p>
+        </p:txBody>
+      </p:sp>
+      <p:sp>
+        <p:nvSpPr>
+          <p:cNvPr id="41" name="TextBox 40"/>
           <p:cNvSpPr txBox="1"/>
           <p:nvPr/>
         </p:nvSpPr>
         <p:spPr>
           <a:xfrm>
-            <a:off x="7909560" y="3511296"/>
-            <a:ext cx="2011680" cy="237744"/>
+            <a:off x="6583680" y="3511296"/>
+            <a:ext cx="1554480" cy="237744"/>
           </a:xfrm>
           <a:prstGeom prst="rect">
             <a:avLst/>
@@ -4601,21 +4769,21 @@
                 </a:solidFill>
                 <a:latin typeface="Open Sans"/>
               </a:rPr>
-              <a:t>11,136</a:t>
-            </a:r>
-          </a:p>
-        </p:txBody>
-      </p:sp>
-      <p:sp>
-        <p:nvSpPr>
-          <p:cNvPr id="38" name="TextBox 37"/>
+              <a:t>36,773</a:t>
+            </a:r>
+          </a:p>
+        </p:txBody>
+      </p:sp>
+      <p:sp>
+        <p:nvSpPr>
+          <p:cNvPr id="42" name="TextBox 41"/>
           <p:cNvSpPr txBox="1"/>
           <p:nvPr/>
         </p:nvSpPr>
         <p:spPr>
           <a:xfrm>
-            <a:off x="10012680" y="3511296"/>
-            <a:ext cx="1463040" cy="237744"/>
+            <a:off x="8183879" y="3511296"/>
+            <a:ext cx="1965960" cy="237744"/>
           </a:xfrm>
           <a:prstGeom prst="rect">
             <a:avLst/>
@@ -4643,6 +4811,48 @@
                 </a:solidFill>
                 <a:latin typeface="Open Sans"/>
               </a:rPr>
+              <a:t>11,136</a:t>
+            </a:r>
+          </a:p>
+        </p:txBody>
+      </p:sp>
+      <p:sp>
+        <p:nvSpPr>
+          <p:cNvPr id="43" name="TextBox 42"/>
+          <p:cNvSpPr txBox="1"/>
+          <p:nvPr/>
+        </p:nvSpPr>
+        <p:spPr>
+          <a:xfrm>
+            <a:off x="10195560" y="3511296"/>
+            <a:ext cx="1280160" cy="237744"/>
+          </a:xfrm>
+          <a:prstGeom prst="rect">
+            <a:avLst/>
+          </a:prstGeom>
+          <a:noFill/>
+        </p:spPr>
+        <p:txBody>
+          <a:bodyPr wrap="square" lIns="0" rIns="0" tIns="0" bIns="0" anchor="t">
+            <a:spAutoFit/>
+          </a:bodyPr>
+          <a:lstStyle/>
+          <a:p>
+            <a:pPr algn="ctr">
+              <a:lnSpc>
+                <a:spcPct val="115000"/>
+              </a:lnSpc>
+              <a:spcAft>
+                <a:spcPts val="0"/>
+              </a:spcAft>
+            </a:pPr>
+            <a:r>
+              <a:rPr sz="1100" b="0">
+                <a:solidFill>
+                  <a:srgbClr val="595A5B"/>
+                </a:solidFill>
+                <a:latin typeface="Open Sans"/>
+              </a:rPr>
               <a:t>43</a:t>
             </a:r>
           </a:p>
@@ -4650,7 +4860,7 @@
       </p:sp>
       <p:sp>
         <p:nvSpPr>
-          <p:cNvPr id="39" name="Rectangle 38"/>
+          <p:cNvPr id="44" name="Rectangle 43"/>
           <p:cNvSpPr/>
           <p:nvPr/>
         </p:nvSpPr>
@@ -4696,14 +4906,14 @@
       </p:sp>
       <p:sp>
         <p:nvSpPr>
-          <p:cNvPr id="40" name="TextBox 39"/>
+          <p:cNvPr id="45" name="TextBox 44"/>
           <p:cNvSpPr txBox="1"/>
           <p:nvPr/>
         </p:nvSpPr>
         <p:spPr>
           <a:xfrm>
             <a:off x="685800" y="3968496"/>
-            <a:ext cx="3291840" cy="237744"/>
+            <a:ext cx="2697480" cy="237744"/>
           </a:xfrm>
           <a:prstGeom prst="rect">
             <a:avLst/>
@@ -4738,14 +4948,14 @@
       </p:sp>
       <p:sp>
         <p:nvSpPr>
-          <p:cNvPr id="41" name="TextBox 40"/>
+          <p:cNvPr id="46" name="TextBox 45"/>
           <p:cNvSpPr txBox="1"/>
           <p:nvPr/>
         </p:nvSpPr>
         <p:spPr>
           <a:xfrm>
-            <a:off x="4069080" y="3968496"/>
-            <a:ext cx="1828800" cy="237744"/>
+            <a:off x="3474720" y="3968496"/>
+            <a:ext cx="1554480" cy="237744"/>
           </a:xfrm>
           <a:prstGeom prst="rect">
             <a:avLst/>
@@ -4780,14 +4990,14 @@
       </p:sp>
       <p:sp>
         <p:nvSpPr>
-          <p:cNvPr id="42" name="TextBox 41"/>
+          <p:cNvPr id="47" name="TextBox 46"/>
           <p:cNvSpPr txBox="1"/>
           <p:nvPr/>
         </p:nvSpPr>
         <p:spPr>
           <a:xfrm>
-            <a:off x="5989320" y="3968496"/>
-            <a:ext cx="1828800" cy="237744"/>
+            <a:off x="5074920" y="3968496"/>
+            <a:ext cx="1463040" cy="237744"/>
           </a:xfrm>
           <a:prstGeom prst="rect">
             <a:avLst/>
@@ -4815,21 +5025,21 @@
                 </a:solidFill>
                 <a:latin typeface="Open Sans"/>
               </a:rPr>
-              <a:t>33,189</a:t>
-            </a:r>
-          </a:p>
-        </p:txBody>
-      </p:sp>
-      <p:sp>
-        <p:nvSpPr>
-          <p:cNvPr id="43" name="TextBox 42"/>
+              <a:t>172,000</a:t>
+            </a:r>
+          </a:p>
+        </p:txBody>
+      </p:sp>
+      <p:sp>
+        <p:nvSpPr>
+          <p:cNvPr id="48" name="TextBox 47"/>
           <p:cNvSpPr txBox="1"/>
           <p:nvPr/>
         </p:nvSpPr>
         <p:spPr>
           <a:xfrm>
-            <a:off x="7909560" y="3968496"/>
-            <a:ext cx="2011680" cy="237744"/>
+            <a:off x="6583680" y="3968496"/>
+            <a:ext cx="1554480" cy="237744"/>
           </a:xfrm>
           <a:prstGeom prst="rect">
             <a:avLst/>
@@ -4857,21 +5067,21 @@
                 </a:solidFill>
                 <a:latin typeface="Open Sans"/>
               </a:rPr>
-              <a:t>14,773</a:t>
-            </a:r>
-          </a:p>
-        </p:txBody>
-      </p:sp>
-      <p:sp>
-        <p:nvSpPr>
-          <p:cNvPr id="44" name="TextBox 43"/>
+              <a:t>33,189</a:t>
+            </a:r>
+          </a:p>
+        </p:txBody>
+      </p:sp>
+      <p:sp>
+        <p:nvSpPr>
+          <p:cNvPr id="49" name="TextBox 48"/>
           <p:cNvSpPr txBox="1"/>
           <p:nvPr/>
         </p:nvSpPr>
         <p:spPr>
           <a:xfrm>
-            <a:off x="10012680" y="3968496"/>
-            <a:ext cx="1463040" cy="237744"/>
+            <a:off x="8183879" y="3968496"/>
+            <a:ext cx="1965960" cy="237744"/>
           </a:xfrm>
           <a:prstGeom prst="rect">
             <a:avLst/>
@@ -4899,21 +5109,21 @@
                 </a:solidFill>
                 <a:latin typeface="Open Sans"/>
               </a:rPr>
-              <a:t>47</a:t>
-            </a:r>
-          </a:p>
-        </p:txBody>
-      </p:sp>
-      <p:sp>
-        <p:nvSpPr>
-          <p:cNvPr id="45" name="TextBox 44"/>
+              <a:t>14,773</a:t>
+            </a:r>
+          </a:p>
+        </p:txBody>
+      </p:sp>
+      <p:sp>
+        <p:nvSpPr>
+          <p:cNvPr id="50" name="TextBox 49"/>
           <p:cNvSpPr txBox="1"/>
           <p:nvPr/>
         </p:nvSpPr>
         <p:spPr>
           <a:xfrm>
-            <a:off x="557784" y="4407408"/>
-            <a:ext cx="11064240" cy="219456"/>
+            <a:off x="10195560" y="3968496"/>
+            <a:ext cx="1280160" cy="237744"/>
           </a:xfrm>
           <a:prstGeom prst="rect">
             <a:avLst/>
@@ -4926,7 +5136,7 @@
           </a:bodyPr>
           <a:lstStyle/>
           <a:p>
-            <a:pPr algn="l">
+            <a:pPr algn="ctr">
               <a:lnSpc>
                 <a:spcPct val="115000"/>
               </a:lnSpc>
@@ -4935,20 +5145,62 @@
               </a:spcAft>
             </a:pPr>
             <a:r>
-              <a:rPr sz="950" b="0">
-                <a:solidFill>
-                  <a:srgbClr val="8A8A8D"/>
+              <a:rPr sz="1100" b="0">
+                <a:solidFill>
+                  <a:srgbClr val="595A5B"/>
                 </a:solidFill>
                 <a:latin typeface="Open Sans"/>
               </a:rPr>
-              <a:t>Source: Semrush, US database, snapshot of 15 August 2026. Authority is Semrush's 0 to 100 measure of overall domain strength.</a:t>
-            </a:r>
-          </a:p>
-        </p:txBody>
-      </p:sp>
-      <p:sp>
-        <p:nvSpPr>
-          <p:cNvPr id="46" name="Rectangle 45"/>
+              <a:t>47</a:t>
+            </a:r>
+          </a:p>
+        </p:txBody>
+      </p:sp>
+      <p:sp>
+        <p:nvSpPr>
+          <p:cNvPr id="51" name="TextBox 50"/>
+          <p:cNvSpPr txBox="1"/>
+          <p:nvPr/>
+        </p:nvSpPr>
+        <p:spPr>
+          <a:xfrm>
+            <a:off x="557784" y="4407408"/>
+            <a:ext cx="11064240" cy="219456"/>
+          </a:xfrm>
+          <a:prstGeom prst="rect">
+            <a:avLst/>
+          </a:prstGeom>
+          <a:noFill/>
+        </p:spPr>
+        <p:txBody>
+          <a:bodyPr wrap="square" lIns="0" rIns="0" tIns="0" bIns="0" anchor="t">
+            <a:spAutoFit/>
+          </a:bodyPr>
+          <a:lstStyle/>
+          <a:p>
+            <a:pPr algn="l">
+              <a:lnSpc>
+                <a:spcPct val="120000"/>
+              </a:lnSpc>
+              <a:spcAft>
+                <a:spcPts val="0"/>
+              </a:spcAft>
+            </a:pPr>
+            <a:r>
+              <a:rPr sz="900" b="0">
+                <a:solidFill>
+                  <a:srgbClr val="8A8A8D"/>
+                </a:solidFill>
+                <a:latin typeface="Open Sans"/>
+              </a:rPr>
+              <a:t>Sources: Semrush, US database, 15 August 2026, and Google site: queries, September 2026. Traffic is a Semrush model rather than measured clicks, applied identically to all five vendors. Page counts are Google estimates and include subdomains.</a:t>
+            </a:r>
+          </a:p>
+        </p:txBody>
+      </p:sp>
+      <p:sp>
+        <p:nvSpPr>
+          <p:cNvPr id="52" name="Rectangle 51"/>
           <p:cNvSpPr/>
           <p:nvPr/>
         </p:nvSpPr>
@@ -4994,7 +5246,7 @@
       </p:sp>
       <p:sp>
         <p:nvSpPr>
-          <p:cNvPr id="47" name="Rectangle 46"/>
+          <p:cNvPr id="53" name="Rectangle 52"/>
           <p:cNvSpPr/>
           <p:nvPr/>
         </p:nvSpPr>
@@ -5038,7 +5290,7 @@
       </p:sp>
       <p:sp>
         <p:nvSpPr>
-          <p:cNvPr id="48" name="TextBox 47"/>
+          <p:cNvPr id="54" name="TextBox 53"/>
           <p:cNvSpPr txBox="1"/>
           <p:nvPr/>
         </p:nvSpPr>
@@ -5092,14 +5344,14 @@
                 </a:solidFill>
                 <a:latin typeface="Open Sans"/>
               </a:rPr>
-              <a:t>Komprise ranks for a sixth of NetApp's keywords and holds a third of its traffic. Each keyword earns 4.1 visits against 1.9 for NetApp, and our authority matches Cohesity on a quarter of the referring domains.</a:t>
-            </a:r>
-          </a:p>
-        </p:txBody>
-      </p:sp>
-      <p:sp>
-        <p:nvSpPr>
-          <p:cNvPr id="49" name="Rectangle 48"/>
+              <a:t>Komprise ranks for 6,139 keywords from around 1,610 indexed pages. NetApp needs roughly 621,000 pages to rank for 39,118. Far more of what we publish is working, and our authority matches Cohesity on a quarter of the referring domains.</a:t>
+            </a:r>
+          </a:p>
+        </p:txBody>
+      </p:sp>
+      <p:sp>
+        <p:nvSpPr>
+          <p:cNvPr id="55" name="Rectangle 54"/>
           <p:cNvSpPr/>
           <p:nvPr/>
         </p:nvSpPr>
@@ -5145,7 +5397,7 @@
       </p:sp>
       <p:sp>
         <p:nvSpPr>
-          <p:cNvPr id="50" name="Rectangle 49"/>
+          <p:cNvPr id="56" name="Rectangle 55"/>
           <p:cNvSpPr/>
           <p:nvPr/>
         </p:nvSpPr>
@@ -5189,7 +5441,7 @@
       </p:sp>
       <p:sp>
         <p:nvSpPr>
-          <p:cNvPr id="51" name="TextBox 50"/>
+          <p:cNvPr id="57" name="TextBox 56"/>
           <p:cNvSpPr txBox="1"/>
           <p:nvPr/>
         </p:nvSpPr>
@@ -5250,7 +5502,7 @@
       </p:sp>
       <p:sp>
         <p:nvSpPr>
-          <p:cNvPr id="52" name="Rectangle 51"/>
+          <p:cNvPr id="58" name="Rectangle 57"/>
           <p:cNvSpPr/>
           <p:nvPr/>
         </p:nvSpPr>
@@ -5294,7 +5546,7 @@
       </p:sp>
       <p:sp>
         <p:nvSpPr>
-          <p:cNvPr id="53" name="Rectangle 52"/>
+          <p:cNvPr id="59" name="Rectangle 58"/>
           <p:cNvSpPr/>
           <p:nvPr/>
         </p:nvSpPr>
@@ -5338,7 +5590,7 @@
       </p:sp>
       <p:sp>
         <p:nvSpPr>
-          <p:cNvPr id="54" name="TextBox 53"/>
+          <p:cNvPr id="60" name="TextBox 59"/>
           <p:cNvSpPr txBox="1"/>
           <p:nvPr/>
         </p:nvSpPr>
@@ -5380,7 +5632,7 @@
       </p:sp>
       <p:sp>
         <p:nvSpPr>
-          <p:cNvPr id="55" name="TextBox 54"/>
+          <p:cNvPr id="61" name="TextBox 60"/>
           <p:cNvSpPr txBox="1"/>
           <p:nvPr/>
         </p:nvSpPr>
@@ -5422,7 +5674,7 @@
       </p:sp>
       <p:sp>
         <p:nvSpPr>
-          <p:cNvPr id="56" name="TextBox 55"/>
+          <p:cNvPr id="62" name="TextBox 61"/>
           <p:cNvSpPr txBox="1"/>
           <p:nvPr/>
         </p:nvSpPr>

</xml_diff>

<commit_message>
Show Komprise traffic as measured Search Console clicks
Per review, the Komprise traffic cell now shows 4,600, the Search Console
twelve-month average, rather than the Semrush estimate of 25,126. The other four
vendors stay on Semrush estimates because Search Console covers only owned
properties.

An asterisk on the cell and a footnote state which figure is measured and which
are modelled, and that estimates typically run several times above measured
clicks. SOURCES.md records that the mixed basis understates Komprise's relative
position by roughly five times.

Also reflowed the footnote so it no longer overlaps the read-out panels, and
removed a comma before "and" in the left panel.

Co-Authored-By: Claude Opus 5 <noreply@anthropic.com>
Claude-Session: https://claude.ai/code/session_01Qb9Qq8GcnmrwCpYXA3jWR9
</commit_message>
<xml_diff>
--- a/Komprise_Vendor_Comparison_Sep2026.pptx
+++ b/Komprise_Vendor_Comparison_Sep2026.pptx
@@ -3533,7 +3533,7 @@
                 </a:solidFill>
                 <a:latin typeface="Open Sans"/>
               </a:rPr>
-              <a:t>Est. Monthly Traffic</a:t>
+              <a:t>Monthly Traffic</a:t>
             </a:r>
           </a:p>
         </p:txBody>
@@ -3875,7 +3875,7 @@
                 </a:solidFill>
                 <a:latin typeface="Open Sans"/>
               </a:rPr>
-              <a:t>25,126</a:t>
+              <a:t>4,600 *</a:t>
             </a:r>
           </a:p>
         </p:txBody>
@@ -5164,8 +5164,8 @@
         </p:nvSpPr>
         <p:spPr>
           <a:xfrm>
-            <a:off x="557784" y="4407408"/>
-            <a:ext cx="11064240" cy="219456"/>
+            <a:off x="557784" y="4389120"/>
+            <a:ext cx="11064240" cy="457200"/>
           </a:xfrm>
           <a:prstGeom prst="rect">
             <a:avLst/>
@@ -5193,7 +5193,7 @@
                 </a:solidFill>
                 <a:latin typeface="Open Sans"/>
               </a:rPr>
-              <a:t>Sources: Semrush, US database, 15 August 2026, and Google site: queries, September 2026. Traffic is a Semrush model rather than measured clicks, applied identically to all five vendors. Page counts are Google estimates and include subdomains.</a:t>
+              <a:t>* Komprise is measured clicks from Google Search Console, twelve-month average to September 2026. The other four are Semrush estimates, which model clicks from ranking position and typically run several times higher. Sources: Semrush 15 August 2026, Google Search Console, Google site: queries September 2026. Page counts are Google estimates and include subdomains.</a:t>
             </a:r>
           </a:p>
         </p:txBody>
@@ -5206,8 +5206,8 @@
         </p:nvSpPr>
         <p:spPr>
           <a:xfrm>
-            <a:off x="502920" y="4736592"/>
-            <a:ext cx="5504688" cy="1316736"/>
+            <a:off x="502920" y="4919472"/>
+            <a:ext cx="5504688" cy="1152144"/>
           </a:xfrm>
           <a:prstGeom prst="rect">
             <a:avLst/>
@@ -5252,8 +5252,8 @@
         </p:nvSpPr>
         <p:spPr>
           <a:xfrm>
-            <a:off x="502920" y="4736592"/>
-            <a:ext cx="54864" cy="1316736"/>
+            <a:off x="502920" y="4919472"/>
+            <a:ext cx="54864" cy="1152144"/>
           </a:xfrm>
           <a:prstGeom prst="rect">
             <a:avLst/>
@@ -5296,8 +5296,8 @@
         </p:nvSpPr>
         <p:spPr>
           <a:xfrm>
-            <a:off x="758952" y="4901184"/>
-            <a:ext cx="5074920" cy="1060704"/>
+            <a:off x="758952" y="5065776"/>
+            <a:ext cx="5074920" cy="950976"/>
           </a:xfrm>
           <a:prstGeom prst="rect">
             <a:avLst/>
@@ -5344,7 +5344,7 @@
                 </a:solidFill>
                 <a:latin typeface="Open Sans"/>
               </a:rPr>
-              <a:t>Komprise ranks for 6,139 keywords from around 1,610 indexed pages. NetApp needs roughly 621,000 pages to rank for 39,118. Far more of what we publish is working, and our authority matches Cohesity on a quarter of the referring domains.</a:t>
+              <a:t>Komprise ranks for 6,139 keywords from around 1,610 indexed pages. NetApp needs roughly 621,000 pages to rank for 39,118. Far more of what we publish is working. Our authority matches Cohesity on a quarter of the referring domains.</a:t>
             </a:r>
           </a:p>
         </p:txBody>
@@ -5357,8 +5357,8 @@
         </p:nvSpPr>
         <p:spPr>
           <a:xfrm>
-            <a:off x="6181344" y="4736592"/>
-            <a:ext cx="5504688" cy="1316736"/>
+            <a:off x="6181344" y="4919472"/>
+            <a:ext cx="5504688" cy="1152144"/>
           </a:xfrm>
           <a:prstGeom prst="rect">
             <a:avLst/>
@@ -5403,8 +5403,8 @@
         </p:nvSpPr>
         <p:spPr>
           <a:xfrm>
-            <a:off x="6181344" y="4736592"/>
-            <a:ext cx="54864" cy="1316736"/>
+            <a:off x="6181344" y="4919472"/>
+            <a:ext cx="54864" cy="1152144"/>
           </a:xfrm>
           <a:prstGeom prst="rect">
             <a:avLst/>
@@ -5447,8 +5447,8 @@
         </p:nvSpPr>
         <p:spPr>
           <a:xfrm>
-            <a:off x="6437376" y="4901184"/>
-            <a:ext cx="5074920" cy="1060704"/>
+            <a:off x="6437376" y="5065776"/>
+            <a:ext cx="5074920" cy="950976"/>
           </a:xfrm>
           <a:prstGeom prst="rect">
             <a:avLst/>
@@ -5508,7 +5508,7 @@
         </p:nvSpPr>
         <p:spPr>
           <a:xfrm>
-            <a:off x="502920" y="6144768"/>
+            <a:off x="502920" y="6163056"/>
             <a:ext cx="11183112" cy="365760"/>
           </a:xfrm>
           <a:prstGeom prst="rect">
@@ -5552,7 +5552,7 @@
         </p:nvSpPr>
         <p:spPr>
           <a:xfrm>
-            <a:off x="502920" y="6144768"/>
+            <a:off x="502920" y="6163056"/>
             <a:ext cx="54864" cy="365760"/>
           </a:xfrm>
           <a:prstGeom prst="rect">
@@ -5596,7 +5596,7 @@
         </p:nvSpPr>
         <p:spPr>
           <a:xfrm>
-            <a:off x="758952" y="6227064"/>
+            <a:off x="758952" y="6245352"/>
             <a:ext cx="10789920" cy="237744"/>
           </a:xfrm>
           <a:prstGeom prst="rect">

</xml_diff>